<commit_message>
Add 3D interactive mouse tilt, dynamic light glare, floating micro-badges, and animated aurora to landing page
</commit_message>
<xml_diff>
--- a/Temar_Lije_Presentation.pptx
+++ b/Temar_Lije_Presentation.pptx
@@ -5,32 +5,32 @@
     <p:sldMasterId id="2147483648" r:id="rId1"/>
   </p:sldMasterIdLst>
   <p:sldIdLst>
-    <p:sldId id="256" r:id="rId7"/>
-    <p:sldId id="257" r:id="rId8"/>
-    <p:sldId id="258" r:id="rId9"/>
-    <p:sldId id="259" r:id="rId10"/>
-    <p:sldId id="260" r:id="rId11"/>
-    <p:sldId id="261" r:id="rId12"/>
-    <p:sldId id="262" r:id="rId13"/>
-    <p:sldId id="263" r:id="rId14"/>
-    <p:sldId id="264" r:id="rId15"/>
-    <p:sldId id="265" r:id="rId16"/>
-    <p:sldId id="266" r:id="rId17"/>
-    <p:sldId id="267" r:id="rId18"/>
-    <p:sldId id="268" r:id="rId19"/>
-    <p:sldId id="269" r:id="rId20"/>
-    <p:sldId id="270" r:id="rId21"/>
-    <p:sldId id="271" r:id="rId22"/>
-    <p:sldId id="272" r:id="rId23"/>
-    <p:sldId id="273" r:id="rId24"/>
-    <p:sldId id="274" r:id="rId25"/>
-    <p:sldId id="275" r:id="rId26"/>
-    <p:sldId id="276" r:id="rId27"/>
-    <p:sldId id="277" r:id="rId28"/>
-    <p:sldId id="278" r:id="rId29"/>
-    <p:sldId id="279" r:id="rId30"/>
+    <p:sldId id="256" r:id="rId2"/>
+    <p:sldId id="257" r:id="rId3"/>
+    <p:sldId id="258" r:id="rId4"/>
+    <p:sldId id="259" r:id="rId5"/>
+    <p:sldId id="260" r:id="rId6"/>
+    <p:sldId id="261" r:id="rId7"/>
+    <p:sldId id="262" r:id="rId8"/>
+    <p:sldId id="263" r:id="rId9"/>
+    <p:sldId id="264" r:id="rId10"/>
+    <p:sldId id="265" r:id="rId11"/>
+    <p:sldId id="266" r:id="rId12"/>
+    <p:sldId id="267" r:id="rId13"/>
+    <p:sldId id="268" r:id="rId14"/>
+    <p:sldId id="269" r:id="rId15"/>
+    <p:sldId id="270" r:id="rId16"/>
+    <p:sldId id="271" r:id="rId17"/>
+    <p:sldId id="272" r:id="rId18"/>
+    <p:sldId id="273" r:id="rId19"/>
+    <p:sldId id="274" r:id="rId20"/>
+    <p:sldId id="275" r:id="rId21"/>
+    <p:sldId id="276" r:id="rId22"/>
+    <p:sldId id="277" r:id="rId23"/>
+    <p:sldId id="278" r:id="rId24"/>
+    <p:sldId id="279" r:id="rId25"/>
   </p:sldIdLst>
-  <p:sldSz cx="12191695" cy="6858000" type="screen4x3"/>
+  <p:sldSz cx="12192000" cy="6858000"/>
   <p:notesSz cx="6858000" cy="9144000"/>
   <p:defaultTextStyle>
     <a:defPPr>
@@ -127,6 +127,22 @@
       </a:defRPr>
     </a:lvl9pPr>
   </p:defaultTextStyle>
+  <p:extLst>
+    <p:ext uri="{EFAFB233-063F-42B5-8137-9DF3F51BA10A}">
+      <p15:sldGuideLst xmlns:p15="http://schemas.microsoft.com/office/powerpoint/2012/main">
+        <p15:guide id="1" orient="horz" pos="2160">
+          <p15:clr>
+            <a:srgbClr val="A4A3A4"/>
+          </p15:clr>
+        </p15:guide>
+        <p15:guide id="2" pos="2880">
+          <p15:clr>
+            <a:srgbClr val="A4A3A4"/>
+          </p15:clr>
+        </p15:guide>
+      </p15:sldGuideLst>
+    </p:ext>
+  </p:extLst>
 </p:presentation>
 </file>
 
@@ -168,10 +184,9 @@
           <a:lstStyle/>
           <a:p>
             <a:r>
-              <a:rPr lang="en-US" smtClean="0"/>
+              <a:rPr lang="en-US"/>
               <a:t>Click to edit Master title style</a:t>
             </a:r>
-            <a:endParaRPr lang="en-US"/>
           </a:p>
         </p:txBody>
       </p:sp>
@@ -287,10 +302,9 @@
           </a:lstStyle>
           <a:p>
             <a:r>
-              <a:rPr lang="en-US" smtClean="0"/>
+              <a:rPr lang="en-US"/>
               <a:t>Click to edit Master subtitle style</a:t>
             </a:r>
-            <a:endParaRPr lang="en-US"/>
           </a:p>
         </p:txBody>
       </p:sp>
@@ -311,7 +325,7 @@
           <a:p>
             <a:fld id="{5BCAD085-E8A6-8845-BD4E-CB4CCA059FC4}" type="datetimeFigureOut">
               <a:rPr lang="en-US" smtClean="0"/>
-              <a:t>1/27/13</a:t>
+              <a:t>8/23/2026</a:t>
             </a:fld>
             <a:endParaRPr lang="en-US"/>
           </a:p>
@@ -405,10 +419,9 @@
           <a:lstStyle/>
           <a:p>
             <a:r>
-              <a:rPr lang="en-US" smtClean="0"/>
+              <a:rPr lang="en-US"/>
               <a:t>Click to edit Master title style</a:t>
             </a:r>
-            <a:endParaRPr lang="en-US"/>
           </a:p>
         </p:txBody>
       </p:sp>
@@ -429,38 +442,37 @@
           <a:p>
             <a:pPr lvl="0"/>
             <a:r>
-              <a:rPr lang="en-US" smtClean="0"/>
+              <a:rPr lang="en-US"/>
               <a:t>Click to edit Master text styles</a:t>
             </a:r>
           </a:p>
           <a:p>
             <a:pPr lvl="1"/>
             <a:r>
-              <a:rPr lang="en-US" smtClean="0"/>
+              <a:rPr lang="en-US"/>
               <a:t>Second level</a:t>
             </a:r>
           </a:p>
           <a:p>
             <a:pPr lvl="2"/>
             <a:r>
-              <a:rPr lang="en-US" smtClean="0"/>
+              <a:rPr lang="en-US"/>
               <a:t>Third level</a:t>
             </a:r>
           </a:p>
           <a:p>
             <a:pPr lvl="3"/>
             <a:r>
-              <a:rPr lang="en-US" smtClean="0"/>
+              <a:rPr lang="en-US"/>
               <a:t>Fourth level</a:t>
             </a:r>
           </a:p>
           <a:p>
             <a:pPr lvl="4"/>
             <a:r>
-              <a:rPr lang="en-US" smtClean="0"/>
+              <a:rPr lang="en-US"/>
               <a:t>Fifth level</a:t>
             </a:r>
-            <a:endParaRPr lang="en-US"/>
           </a:p>
         </p:txBody>
       </p:sp>
@@ -481,7 +493,7 @@
           <a:p>
             <a:fld id="{5BCAD085-E8A6-8845-BD4E-CB4CCA059FC4}" type="datetimeFigureOut">
               <a:rPr lang="en-US" smtClean="0"/>
-              <a:t>1/27/13</a:t>
+              <a:t>8/23/2026</a:t>
             </a:fld>
             <a:endParaRPr lang="en-US"/>
           </a:p>
@@ -580,10 +592,9 @@
           <a:lstStyle/>
           <a:p>
             <a:r>
-              <a:rPr lang="en-US" smtClean="0"/>
+              <a:rPr lang="en-US"/>
               <a:t>Click to edit Master title style</a:t>
             </a:r>
-            <a:endParaRPr lang="en-US"/>
           </a:p>
         </p:txBody>
       </p:sp>
@@ -609,38 +620,37 @@
           <a:p>
             <a:pPr lvl="0"/>
             <a:r>
-              <a:rPr lang="en-US" smtClean="0"/>
+              <a:rPr lang="en-US"/>
               <a:t>Click to edit Master text styles</a:t>
             </a:r>
           </a:p>
           <a:p>
             <a:pPr lvl="1"/>
             <a:r>
-              <a:rPr lang="en-US" smtClean="0"/>
+              <a:rPr lang="en-US"/>
               <a:t>Second level</a:t>
             </a:r>
           </a:p>
           <a:p>
             <a:pPr lvl="2"/>
             <a:r>
-              <a:rPr lang="en-US" smtClean="0"/>
+              <a:rPr lang="en-US"/>
               <a:t>Third level</a:t>
             </a:r>
           </a:p>
           <a:p>
             <a:pPr lvl="3"/>
             <a:r>
-              <a:rPr lang="en-US" smtClean="0"/>
+              <a:rPr lang="en-US"/>
               <a:t>Fourth level</a:t>
             </a:r>
           </a:p>
           <a:p>
             <a:pPr lvl="4"/>
             <a:r>
-              <a:rPr lang="en-US" smtClean="0"/>
+              <a:rPr lang="en-US"/>
               <a:t>Fifth level</a:t>
             </a:r>
-            <a:endParaRPr lang="en-US"/>
           </a:p>
         </p:txBody>
       </p:sp>
@@ -661,7 +671,7 @@
           <a:p>
             <a:fld id="{5BCAD085-E8A6-8845-BD4E-CB4CCA059FC4}" type="datetimeFigureOut">
               <a:rPr lang="en-US" smtClean="0"/>
-              <a:t>1/27/13</a:t>
+              <a:t>8/23/2026</a:t>
             </a:fld>
             <a:endParaRPr lang="en-US"/>
           </a:p>
@@ -755,10 +765,9 @@
           <a:lstStyle/>
           <a:p>
             <a:r>
-              <a:rPr lang="en-US" smtClean="0"/>
+              <a:rPr lang="en-US"/>
               <a:t>Click to edit Master title style</a:t>
             </a:r>
-            <a:endParaRPr lang="en-US"/>
           </a:p>
         </p:txBody>
       </p:sp>
@@ -779,38 +788,37 @@
           <a:p>
             <a:pPr lvl="0"/>
             <a:r>
-              <a:rPr lang="en-US" smtClean="0"/>
+              <a:rPr lang="en-US"/>
               <a:t>Click to edit Master text styles</a:t>
             </a:r>
           </a:p>
           <a:p>
             <a:pPr lvl="1"/>
             <a:r>
-              <a:rPr lang="en-US" smtClean="0"/>
+              <a:rPr lang="en-US"/>
               <a:t>Second level</a:t>
             </a:r>
           </a:p>
           <a:p>
             <a:pPr lvl="2"/>
             <a:r>
-              <a:rPr lang="en-US" smtClean="0"/>
+              <a:rPr lang="en-US"/>
               <a:t>Third level</a:t>
             </a:r>
           </a:p>
           <a:p>
             <a:pPr lvl="3"/>
             <a:r>
-              <a:rPr lang="en-US" smtClean="0"/>
+              <a:rPr lang="en-US"/>
               <a:t>Fourth level</a:t>
             </a:r>
           </a:p>
           <a:p>
             <a:pPr lvl="4"/>
             <a:r>
-              <a:rPr lang="en-US" smtClean="0"/>
+              <a:rPr lang="en-US"/>
               <a:t>Fifth level</a:t>
             </a:r>
-            <a:endParaRPr lang="en-US"/>
           </a:p>
         </p:txBody>
       </p:sp>
@@ -831,7 +839,7 @@
           <a:p>
             <a:fld id="{5BCAD085-E8A6-8845-BD4E-CB4CCA059FC4}" type="datetimeFigureOut">
               <a:rPr lang="en-US" smtClean="0"/>
-              <a:t>1/27/13</a:t>
+              <a:t>8/23/2026</a:t>
             </a:fld>
             <a:endParaRPr lang="en-US"/>
           </a:p>
@@ -934,10 +942,9 @@
           </a:lstStyle>
           <a:p>
             <a:r>
-              <a:rPr lang="en-US" smtClean="0"/>
+              <a:rPr lang="en-US"/>
               <a:t>Click to edit Master title style</a:t>
             </a:r>
-            <a:endParaRPr lang="en-US"/>
           </a:p>
         </p:txBody>
       </p:sp>
@@ -1054,7 +1061,7 @@
           <a:p>
             <a:pPr lvl="0"/>
             <a:r>
-              <a:rPr lang="en-US" smtClean="0"/>
+              <a:rPr lang="en-US"/>
               <a:t>Click to edit Master text styles</a:t>
             </a:r>
           </a:p>
@@ -1077,7 +1084,7 @@
           <a:p>
             <a:fld id="{5BCAD085-E8A6-8845-BD4E-CB4CCA059FC4}" type="datetimeFigureOut">
               <a:rPr lang="en-US" smtClean="0"/>
-              <a:t>1/27/13</a:t>
+              <a:t>8/23/2026</a:t>
             </a:fld>
             <a:endParaRPr lang="en-US"/>
           </a:p>
@@ -1171,10 +1178,9 @@
           <a:lstStyle/>
           <a:p>
             <a:r>
-              <a:rPr lang="en-US" smtClean="0"/>
+              <a:rPr lang="en-US"/>
               <a:t>Click to edit Master title style</a:t>
             </a:r>
-            <a:endParaRPr lang="en-US"/>
           </a:p>
         </p:txBody>
       </p:sp>
@@ -1228,38 +1234,37 @@
           <a:p>
             <a:pPr lvl="0"/>
             <a:r>
-              <a:rPr lang="en-US" smtClean="0"/>
+              <a:rPr lang="en-US"/>
               <a:t>Click to edit Master text styles</a:t>
             </a:r>
           </a:p>
           <a:p>
             <a:pPr lvl="1"/>
             <a:r>
-              <a:rPr lang="en-US" smtClean="0"/>
+              <a:rPr lang="en-US"/>
               <a:t>Second level</a:t>
             </a:r>
           </a:p>
           <a:p>
             <a:pPr lvl="2"/>
             <a:r>
-              <a:rPr lang="en-US" smtClean="0"/>
+              <a:rPr lang="en-US"/>
               <a:t>Third level</a:t>
             </a:r>
           </a:p>
           <a:p>
             <a:pPr lvl="3"/>
             <a:r>
-              <a:rPr lang="en-US" smtClean="0"/>
+              <a:rPr lang="en-US"/>
               <a:t>Fourth level</a:t>
             </a:r>
           </a:p>
           <a:p>
             <a:pPr lvl="4"/>
             <a:r>
-              <a:rPr lang="en-US" smtClean="0"/>
+              <a:rPr lang="en-US"/>
               <a:t>Fifth level</a:t>
             </a:r>
-            <a:endParaRPr lang="en-US"/>
           </a:p>
         </p:txBody>
       </p:sp>
@@ -1313,38 +1318,37 @@
           <a:p>
             <a:pPr lvl="0"/>
             <a:r>
-              <a:rPr lang="en-US" smtClean="0"/>
+              <a:rPr lang="en-US"/>
               <a:t>Click to edit Master text styles</a:t>
             </a:r>
           </a:p>
           <a:p>
             <a:pPr lvl="1"/>
             <a:r>
-              <a:rPr lang="en-US" smtClean="0"/>
+              <a:rPr lang="en-US"/>
               <a:t>Second level</a:t>
             </a:r>
           </a:p>
           <a:p>
             <a:pPr lvl="2"/>
             <a:r>
-              <a:rPr lang="en-US" smtClean="0"/>
+              <a:rPr lang="en-US"/>
               <a:t>Third level</a:t>
             </a:r>
           </a:p>
           <a:p>
             <a:pPr lvl="3"/>
             <a:r>
-              <a:rPr lang="en-US" smtClean="0"/>
+              <a:rPr lang="en-US"/>
               <a:t>Fourth level</a:t>
             </a:r>
           </a:p>
           <a:p>
             <a:pPr lvl="4"/>
             <a:r>
-              <a:rPr lang="en-US" smtClean="0"/>
+              <a:rPr lang="en-US"/>
               <a:t>Fifth level</a:t>
             </a:r>
-            <a:endParaRPr lang="en-US"/>
           </a:p>
         </p:txBody>
       </p:sp>
@@ -1365,7 +1369,7 @@
           <a:p>
             <a:fld id="{5BCAD085-E8A6-8845-BD4E-CB4CCA059FC4}" type="datetimeFigureOut">
               <a:rPr lang="en-US" smtClean="0"/>
-              <a:t>1/27/13</a:t>
+              <a:t>8/23/2026</a:t>
             </a:fld>
             <a:endParaRPr lang="en-US"/>
           </a:p>
@@ -1463,10 +1467,9 @@
           </a:lstStyle>
           <a:p>
             <a:r>
-              <a:rPr lang="en-US" smtClean="0"/>
+              <a:rPr lang="en-US"/>
               <a:t>Click to edit Master title style</a:t>
             </a:r>
-            <a:endParaRPr lang="en-US"/>
           </a:p>
         </p:txBody>
       </p:sp>
@@ -1529,7 +1532,7 @@
           <a:p>
             <a:pPr lvl="0"/>
             <a:r>
-              <a:rPr lang="en-US" smtClean="0"/>
+              <a:rPr lang="en-US"/>
               <a:t>Click to edit Master text styles</a:t>
             </a:r>
           </a:p>
@@ -1585,38 +1588,37 @@
           <a:p>
             <a:pPr lvl="0"/>
             <a:r>
-              <a:rPr lang="en-US" smtClean="0"/>
+              <a:rPr lang="en-US"/>
               <a:t>Click to edit Master text styles</a:t>
             </a:r>
           </a:p>
           <a:p>
             <a:pPr lvl="1"/>
             <a:r>
-              <a:rPr lang="en-US" smtClean="0"/>
+              <a:rPr lang="en-US"/>
               <a:t>Second level</a:t>
             </a:r>
           </a:p>
           <a:p>
             <a:pPr lvl="2"/>
             <a:r>
-              <a:rPr lang="en-US" smtClean="0"/>
+              <a:rPr lang="en-US"/>
               <a:t>Third level</a:t>
             </a:r>
           </a:p>
           <a:p>
             <a:pPr lvl="3"/>
             <a:r>
-              <a:rPr lang="en-US" smtClean="0"/>
+              <a:rPr lang="en-US"/>
               <a:t>Fourth level</a:t>
             </a:r>
           </a:p>
           <a:p>
             <a:pPr lvl="4"/>
             <a:r>
-              <a:rPr lang="en-US" smtClean="0"/>
+              <a:rPr lang="en-US"/>
               <a:t>Fifth level</a:t>
             </a:r>
-            <a:endParaRPr lang="en-US"/>
           </a:p>
         </p:txBody>
       </p:sp>
@@ -1679,7 +1681,7 @@
           <a:p>
             <a:pPr lvl="0"/>
             <a:r>
-              <a:rPr lang="en-US" smtClean="0"/>
+              <a:rPr lang="en-US"/>
               <a:t>Click to edit Master text styles</a:t>
             </a:r>
           </a:p>
@@ -1735,38 +1737,37 @@
           <a:p>
             <a:pPr lvl="0"/>
             <a:r>
-              <a:rPr lang="en-US" smtClean="0"/>
+              <a:rPr lang="en-US"/>
               <a:t>Click to edit Master text styles</a:t>
             </a:r>
           </a:p>
           <a:p>
             <a:pPr lvl="1"/>
             <a:r>
-              <a:rPr lang="en-US" smtClean="0"/>
+              <a:rPr lang="en-US"/>
               <a:t>Second level</a:t>
             </a:r>
           </a:p>
           <a:p>
             <a:pPr lvl="2"/>
             <a:r>
-              <a:rPr lang="en-US" smtClean="0"/>
+              <a:rPr lang="en-US"/>
               <a:t>Third level</a:t>
             </a:r>
           </a:p>
           <a:p>
             <a:pPr lvl="3"/>
             <a:r>
-              <a:rPr lang="en-US" smtClean="0"/>
+              <a:rPr lang="en-US"/>
               <a:t>Fourth level</a:t>
             </a:r>
           </a:p>
           <a:p>
             <a:pPr lvl="4"/>
             <a:r>
-              <a:rPr lang="en-US" smtClean="0"/>
+              <a:rPr lang="en-US"/>
               <a:t>Fifth level</a:t>
             </a:r>
-            <a:endParaRPr lang="en-US"/>
           </a:p>
         </p:txBody>
       </p:sp>
@@ -1787,7 +1788,7 @@
           <a:p>
             <a:fld id="{5BCAD085-E8A6-8845-BD4E-CB4CCA059FC4}" type="datetimeFigureOut">
               <a:rPr lang="en-US" smtClean="0"/>
-              <a:t>1/27/13</a:t>
+              <a:t>8/23/2026</a:t>
             </a:fld>
             <a:endParaRPr lang="en-US"/>
           </a:p>
@@ -1881,10 +1882,9 @@
           <a:lstStyle/>
           <a:p>
             <a:r>
-              <a:rPr lang="en-US" smtClean="0"/>
+              <a:rPr lang="en-US"/>
               <a:t>Click to edit Master title style</a:t>
             </a:r>
-            <a:endParaRPr lang="en-US"/>
           </a:p>
         </p:txBody>
       </p:sp>
@@ -1905,7 +1905,7 @@
           <a:p>
             <a:fld id="{5BCAD085-E8A6-8845-BD4E-CB4CCA059FC4}" type="datetimeFigureOut">
               <a:rPr lang="en-US" smtClean="0"/>
-              <a:t>1/27/13</a:t>
+              <a:t>8/23/2026</a:t>
             </a:fld>
             <a:endParaRPr lang="en-US"/>
           </a:p>
@@ -2000,7 +2000,7 @@
           <a:p>
             <a:fld id="{5BCAD085-E8A6-8845-BD4E-CB4CCA059FC4}" type="datetimeFigureOut">
               <a:rPr lang="en-US" smtClean="0"/>
-              <a:t>1/27/13</a:t>
+              <a:t>8/23/2026</a:t>
             </a:fld>
             <a:endParaRPr lang="en-US"/>
           </a:p>
@@ -2103,10 +2103,9 @@
           </a:lstStyle>
           <a:p>
             <a:r>
-              <a:rPr lang="en-US" smtClean="0"/>
+              <a:rPr lang="en-US"/>
               <a:t>Click to edit Master title style</a:t>
             </a:r>
-            <a:endParaRPr lang="en-US"/>
           </a:p>
         </p:txBody>
       </p:sp>
@@ -2160,38 +2159,37 @@
           <a:p>
             <a:pPr lvl="0"/>
             <a:r>
-              <a:rPr lang="en-US" smtClean="0"/>
+              <a:rPr lang="en-US"/>
               <a:t>Click to edit Master text styles</a:t>
             </a:r>
           </a:p>
           <a:p>
             <a:pPr lvl="1"/>
             <a:r>
-              <a:rPr lang="en-US" smtClean="0"/>
+              <a:rPr lang="en-US"/>
               <a:t>Second level</a:t>
             </a:r>
           </a:p>
           <a:p>
             <a:pPr lvl="2"/>
             <a:r>
-              <a:rPr lang="en-US" smtClean="0"/>
+              <a:rPr lang="en-US"/>
               <a:t>Third level</a:t>
             </a:r>
           </a:p>
           <a:p>
             <a:pPr lvl="3"/>
             <a:r>
-              <a:rPr lang="en-US" smtClean="0"/>
+              <a:rPr lang="en-US"/>
               <a:t>Fourth level</a:t>
             </a:r>
           </a:p>
           <a:p>
             <a:pPr lvl="4"/>
             <a:r>
-              <a:rPr lang="en-US" smtClean="0"/>
+              <a:rPr lang="en-US"/>
               <a:t>Fifth level</a:t>
             </a:r>
-            <a:endParaRPr lang="en-US"/>
           </a:p>
         </p:txBody>
       </p:sp>
@@ -2254,7 +2252,7 @@
           <a:p>
             <a:pPr lvl="0"/>
             <a:r>
-              <a:rPr lang="en-US" smtClean="0"/>
+              <a:rPr lang="en-US"/>
               <a:t>Click to edit Master text styles</a:t>
             </a:r>
           </a:p>
@@ -2277,7 +2275,7 @@
           <a:p>
             <a:fld id="{5BCAD085-E8A6-8845-BD4E-CB4CCA059FC4}" type="datetimeFigureOut">
               <a:rPr lang="en-US" smtClean="0"/>
-              <a:t>1/27/13</a:t>
+              <a:t>8/23/2026</a:t>
             </a:fld>
             <a:endParaRPr lang="en-US"/>
           </a:p>
@@ -2380,10 +2378,9 @@
           </a:lstStyle>
           <a:p>
             <a:r>
-              <a:rPr lang="en-US" smtClean="0"/>
+              <a:rPr lang="en-US"/>
               <a:t>Click to edit Master title style</a:t>
             </a:r>
-            <a:endParaRPr lang="en-US"/>
           </a:p>
         </p:txBody>
       </p:sp>
@@ -2507,7 +2504,7 @@
           <a:p>
             <a:pPr lvl="0"/>
             <a:r>
-              <a:rPr lang="en-US" smtClean="0"/>
+              <a:rPr lang="en-US"/>
               <a:t>Click to edit Master text styles</a:t>
             </a:r>
           </a:p>
@@ -2530,7 +2527,7 @@
           <a:p>
             <a:fld id="{5BCAD085-E8A6-8845-BD4E-CB4CCA059FC4}" type="datetimeFigureOut">
               <a:rPr lang="en-US" smtClean="0"/>
-              <a:t>1/27/13</a:t>
+              <a:t>8/23/2026</a:t>
             </a:fld>
             <a:endParaRPr lang="en-US"/>
           </a:p>
@@ -2639,10 +2636,9 @@
           <a:lstStyle/>
           <a:p>
             <a:r>
-              <a:rPr lang="en-US" smtClean="0"/>
+              <a:rPr lang="en-US"/>
               <a:t>Click to edit Master title style</a:t>
             </a:r>
-            <a:endParaRPr lang="en-US"/>
           </a:p>
         </p:txBody>
       </p:sp>
@@ -2673,38 +2669,37 @@
           <a:p>
             <a:pPr lvl="0"/>
             <a:r>
-              <a:rPr lang="en-US" smtClean="0"/>
+              <a:rPr lang="en-US"/>
               <a:t>Click to edit Master text styles</a:t>
             </a:r>
           </a:p>
           <a:p>
             <a:pPr lvl="1"/>
             <a:r>
-              <a:rPr lang="en-US" smtClean="0"/>
+              <a:rPr lang="en-US"/>
               <a:t>Second level</a:t>
             </a:r>
           </a:p>
           <a:p>
             <a:pPr lvl="2"/>
             <a:r>
-              <a:rPr lang="en-US" smtClean="0"/>
+              <a:rPr lang="en-US"/>
               <a:t>Third level</a:t>
             </a:r>
           </a:p>
           <a:p>
             <a:pPr lvl="3"/>
             <a:r>
-              <a:rPr lang="en-US" smtClean="0"/>
+              <a:rPr lang="en-US"/>
               <a:t>Fourth level</a:t>
             </a:r>
           </a:p>
           <a:p>
             <a:pPr lvl="4"/>
             <a:r>
-              <a:rPr lang="en-US" smtClean="0"/>
+              <a:rPr lang="en-US"/>
               <a:t>Fifth level</a:t>
             </a:r>
-            <a:endParaRPr lang="en-US"/>
           </a:p>
         </p:txBody>
       </p:sp>
@@ -2743,7 +2738,7 @@
           <a:p>
             <a:fld id="{5BCAD085-E8A6-8845-BD4E-CB4CCA059FC4}" type="datetimeFigureOut">
               <a:rPr lang="en-US" smtClean="0"/>
-              <a:t>1/27/13</a:t>
+              <a:t>8/23/2026</a:t>
             </a:fld>
             <a:endParaRPr lang="en-US"/>
           </a:p>
@@ -3102,7 +3097,7 @@
 </file>
 
 <file path=ppt/slides/slide1.xml><?xml version="1.0" encoding="utf-8"?>
-<p:sld xmlns:a="http://schemas.openxmlformats.org/drawingml/2006/main" xmlns:p="http://schemas.openxmlformats.org/presentationml/2006/main" xmlns:r="http://schemas.openxmlformats.org/officeDocument/2006/relationships">
+<p:sld xmlns:a="http://schemas.openxmlformats.org/drawingml/2006/main" xmlns:r="http://schemas.openxmlformats.org/officeDocument/2006/relationships" xmlns:p="http://schemas.openxmlformats.org/presentationml/2006/main">
   <p:cSld>
     <p:spTree>
       <p:nvGrpSpPr>
@@ -3110,7 +3105,14 @@
         <p:cNvGrpSpPr/>
         <p:nvPr/>
       </p:nvGrpSpPr>
-      <p:grpSpPr/>
+      <p:grpSpPr>
+        <a:xfrm>
+          <a:off x="0" y="0"/>
+          <a:ext cx="0" cy="0"/>
+          <a:chOff x="0" y="0"/>
+          <a:chExt cx="0" cy="0"/>
+        </a:xfrm>
+      </p:grpSpPr>
       <p:sp>
         <p:nvSpPr>
           <p:cNvPr id="2" name="Rectangle 1"/>
@@ -3151,6 +3153,7 @@
           <a:lstStyle/>
           <a:p>
             <a:pPr algn="ctr"/>
+            <a:endParaRPr/>
           </a:p>
         </p:txBody>
       </p:sp>
@@ -3192,7 +3195,7 @@
           </a:fontRef>
         </p:style>
         <p:txBody>
-          <a:bodyPr rtlCol="0" anchor="ctr" lIns="457200" rIns="457200" tIns="548640"/>
+          <a:bodyPr lIns="457200" tIns="548640" rIns="457200" rtlCol="0" anchor="ctr"/>
           <a:lstStyle/>
           <a:p>
             <a:pPr algn="ctr">
@@ -3203,6 +3206,7 @@
               </a:defRPr>
             </a:pPr>
             <a:r>
+              <a:rPr dirty="0"/>
               <a:t>FINAL PROJECT DEFENSE</a:t>
             </a:r>
           </a:p>
@@ -3218,7 +3222,24 @@
               </a:defRPr>
             </a:pPr>
             <a:r>
-              <a:t>Temar Lije (ተማር ልጅ)</a:t>
+              <a:rPr dirty="0"/>
+              <a:t>Temar Lije (</a:t>
+            </a:r>
+            <a:r>
+              <a:rPr dirty="0" err="1"/>
+              <a:t>ተማር</a:t>
+            </a:r>
+            <a:r>
+              <a:rPr dirty="0"/>
+              <a:t> ል</a:t>
+            </a:r>
+            <a:r>
+              <a:rPr lang="am-ET" dirty="0"/>
+              <a:t>ጄ</a:t>
+            </a:r>
+            <a:r>
+              <a:rPr dirty="0"/>
+              <a:t>)</a:t>
             </a:r>
           </a:p>
           <a:p>
@@ -3233,6 +3254,7 @@
               </a:defRPr>
             </a:pPr>
             <a:r>
+              <a:rPr dirty="0"/>
               <a:t>Next-Generation Real-Time Collaborative Learning Management System</a:t>
             </a:r>
           </a:p>
@@ -3248,6 +3270,7 @@
               </a:defRPr>
             </a:pPr>
             <a:r>
+              <a:rPr dirty="0"/>
               <a:t>Empowering Educators &amp; Students with Real-Time Study Groups, Timed Assessments, Audio Voice Notes &amp; Enterprise Cloud High Availability.</a:t>
             </a:r>
           </a:p>
@@ -3263,6 +3286,7 @@
               </a:defRPr>
             </a:pPr>
             <a:r>
+              <a:rPr dirty="0"/>
               <a:t>🌐 Live on Azure: https://temar-lije.southafricanorth.cloudapp.azure.com</a:t>
             </a:r>
           </a:p>
@@ -3306,7 +3330,7 @@
           </a:fontRef>
         </p:style>
         <p:txBody>
-          <a:bodyPr rtlCol="0" anchor="ctr" lIns="365760" rIns="365760" tIns="548640"/>
+          <a:bodyPr lIns="365760" tIns="548640" rIns="365760" rtlCol="0" anchor="ctr"/>
           <a:lstStyle/>
           <a:p>
             <a:pPr algn="ctr">
@@ -3466,7 +3490,7 @@
 </file>
 
 <file path=ppt/slides/slide10.xml><?xml version="1.0" encoding="utf-8"?>
-<p:sld xmlns:a="http://schemas.openxmlformats.org/drawingml/2006/main" xmlns:p="http://schemas.openxmlformats.org/presentationml/2006/main" xmlns:r="http://schemas.openxmlformats.org/officeDocument/2006/relationships">
+<p:sld xmlns:a="http://schemas.openxmlformats.org/drawingml/2006/main" xmlns:r="http://schemas.openxmlformats.org/officeDocument/2006/relationships" xmlns:p="http://schemas.openxmlformats.org/presentationml/2006/main">
   <p:cSld>
     <p:spTree>
       <p:nvGrpSpPr>
@@ -3474,7 +3498,14 @@
         <p:cNvGrpSpPr/>
         <p:nvPr/>
       </p:nvGrpSpPr>
-      <p:grpSpPr/>
+      <p:grpSpPr>
+        <a:xfrm>
+          <a:off x="0" y="0"/>
+          <a:ext cx="0" cy="0"/>
+          <a:chOff x="0" y="0"/>
+          <a:chExt cx="0" cy="0"/>
+        </a:xfrm>
+      </p:grpSpPr>
       <p:sp>
         <p:nvSpPr>
           <p:cNvPr id="2" name="Rectangle 1"/>
@@ -3515,6 +3546,7 @@
           <a:lstStyle/>
           <a:p>
             <a:pPr algn="ctr"/>
+            <a:endParaRPr/>
           </a:p>
         </p:txBody>
       </p:sp>
@@ -3628,6 +3660,7 @@
           <a:lstStyle/>
           <a:p>
             <a:pPr algn="ctr"/>
+            <a:endParaRPr/>
           </a:p>
         </p:txBody>
       </p:sp>
@@ -3723,7 +3756,7 @@
           </a:fontRef>
         </p:style>
         <p:txBody>
-          <a:bodyPr rtlCol="0" anchor="ctr" lIns="365760" tIns="365760"/>
+          <a:bodyPr lIns="365760" tIns="365760" rtlCol="0" anchor="ctr"/>
           <a:lstStyle/>
           <a:p>
             <a:pPr algn="ctr">
@@ -3831,7 +3864,7 @@
           </a:fontRef>
         </p:style>
         <p:txBody>
-          <a:bodyPr rtlCol="0" anchor="ctr" lIns="365760" tIns="365760"/>
+          <a:bodyPr lIns="365760" tIns="365760" rtlCol="0" anchor="ctr"/>
           <a:lstStyle/>
           <a:p>
             <a:pPr algn="ctr">
@@ -3910,7 +3943,7 @@
 </file>
 
 <file path=ppt/slides/slide11.xml><?xml version="1.0" encoding="utf-8"?>
-<p:sld xmlns:a="http://schemas.openxmlformats.org/drawingml/2006/main" xmlns:p="http://schemas.openxmlformats.org/presentationml/2006/main" xmlns:r="http://schemas.openxmlformats.org/officeDocument/2006/relationships">
+<p:sld xmlns:a="http://schemas.openxmlformats.org/drawingml/2006/main" xmlns:r="http://schemas.openxmlformats.org/officeDocument/2006/relationships" xmlns:p="http://schemas.openxmlformats.org/presentationml/2006/main">
   <p:cSld>
     <p:spTree>
       <p:nvGrpSpPr>
@@ -3918,7 +3951,14 @@
         <p:cNvGrpSpPr/>
         <p:nvPr/>
       </p:nvGrpSpPr>
-      <p:grpSpPr/>
+      <p:grpSpPr>
+        <a:xfrm>
+          <a:off x="0" y="0"/>
+          <a:ext cx="0" cy="0"/>
+          <a:chOff x="0" y="0"/>
+          <a:chExt cx="0" cy="0"/>
+        </a:xfrm>
+      </p:grpSpPr>
       <p:sp>
         <p:nvSpPr>
           <p:cNvPr id="2" name="Rectangle 1"/>
@@ -3959,6 +3999,7 @@
           <a:lstStyle/>
           <a:p>
             <a:pPr algn="ctr"/>
+            <a:endParaRPr/>
           </a:p>
         </p:txBody>
       </p:sp>
@@ -4072,6 +4113,7 @@
           <a:lstStyle/>
           <a:p>
             <a:pPr algn="ctr"/>
+            <a:endParaRPr/>
           </a:p>
         </p:txBody>
       </p:sp>
@@ -4167,7 +4209,7 @@
           </a:fontRef>
         </p:style>
         <p:txBody>
-          <a:bodyPr rtlCol="0" anchor="ctr" lIns="274320" tIns="365760"/>
+          <a:bodyPr lIns="274320" tIns="365760" rtlCol="0" anchor="ctr"/>
           <a:lstStyle/>
           <a:p>
             <a:pPr algn="ctr">
@@ -4240,7 +4282,7 @@
           </a:fontRef>
         </p:style>
         <p:txBody>
-          <a:bodyPr rtlCol="0" anchor="ctr" lIns="274320" tIns="365760"/>
+          <a:bodyPr lIns="274320" tIns="365760" rtlCol="0" anchor="ctr"/>
           <a:lstStyle/>
           <a:p>
             <a:pPr algn="ctr">
@@ -4313,7 +4355,7 @@
           </a:fontRef>
         </p:style>
         <p:txBody>
-          <a:bodyPr rtlCol="0" anchor="ctr" lIns="274320" tIns="365760"/>
+          <a:bodyPr lIns="274320" tIns="365760" rtlCol="0" anchor="ctr"/>
           <a:lstStyle/>
           <a:p>
             <a:pPr algn="ctr">
@@ -4357,7 +4399,7 @@
 </file>
 
 <file path=ppt/slides/slide12.xml><?xml version="1.0" encoding="utf-8"?>
-<p:sld xmlns:a="http://schemas.openxmlformats.org/drawingml/2006/main" xmlns:p="http://schemas.openxmlformats.org/presentationml/2006/main" xmlns:r="http://schemas.openxmlformats.org/officeDocument/2006/relationships">
+<p:sld xmlns:a="http://schemas.openxmlformats.org/drawingml/2006/main" xmlns:r="http://schemas.openxmlformats.org/officeDocument/2006/relationships" xmlns:p="http://schemas.openxmlformats.org/presentationml/2006/main">
   <p:cSld>
     <p:spTree>
       <p:nvGrpSpPr>
@@ -4365,7 +4407,14 @@
         <p:cNvGrpSpPr/>
         <p:nvPr/>
       </p:nvGrpSpPr>
-      <p:grpSpPr/>
+      <p:grpSpPr>
+        <a:xfrm>
+          <a:off x="0" y="0"/>
+          <a:ext cx="0" cy="0"/>
+          <a:chOff x="0" y="0"/>
+          <a:chExt cx="0" cy="0"/>
+        </a:xfrm>
+      </p:grpSpPr>
       <p:sp>
         <p:nvSpPr>
           <p:cNvPr id="2" name="Rectangle 1"/>
@@ -4406,6 +4455,7 @@
           <a:lstStyle/>
           <a:p>
             <a:pPr algn="ctr"/>
+            <a:endParaRPr/>
           </a:p>
         </p:txBody>
       </p:sp>
@@ -4519,6 +4569,7 @@
           <a:lstStyle/>
           <a:p>
             <a:pPr algn="ctr"/>
+            <a:endParaRPr/>
           </a:p>
         </p:txBody>
       </p:sp>
@@ -4614,7 +4665,7 @@
           </a:fontRef>
         </p:style>
         <p:txBody>
-          <a:bodyPr rtlCol="0" anchor="ctr" lIns="365760" tIns="365760"/>
+          <a:bodyPr lIns="365760" tIns="365760" rtlCol="0" anchor="ctr"/>
           <a:lstStyle/>
           <a:p>
             <a:pPr algn="ctr">
@@ -4749,7 +4800,7 @@
           </a:fontRef>
         </p:style>
         <p:txBody>
-          <a:bodyPr rtlCol="0" anchor="ctr" lIns="365760" tIns="365760"/>
+          <a:bodyPr lIns="365760" tIns="365760" rtlCol="0" anchor="ctr"/>
           <a:lstStyle/>
           <a:p>
             <a:pPr algn="ctr">
@@ -4855,7 +4906,7 @@
 </file>
 
 <file path=ppt/slides/slide13.xml><?xml version="1.0" encoding="utf-8"?>
-<p:sld xmlns:a="http://schemas.openxmlformats.org/drawingml/2006/main" xmlns:p="http://schemas.openxmlformats.org/presentationml/2006/main" xmlns:r="http://schemas.openxmlformats.org/officeDocument/2006/relationships">
+<p:sld xmlns:a="http://schemas.openxmlformats.org/drawingml/2006/main" xmlns:r="http://schemas.openxmlformats.org/officeDocument/2006/relationships" xmlns:p="http://schemas.openxmlformats.org/presentationml/2006/main">
   <p:cSld>
     <p:spTree>
       <p:nvGrpSpPr>
@@ -4863,7 +4914,14 @@
         <p:cNvGrpSpPr/>
         <p:nvPr/>
       </p:nvGrpSpPr>
-      <p:grpSpPr/>
+      <p:grpSpPr>
+        <a:xfrm>
+          <a:off x="0" y="0"/>
+          <a:ext cx="0" cy="0"/>
+          <a:chOff x="0" y="0"/>
+          <a:chExt cx="0" cy="0"/>
+        </a:xfrm>
+      </p:grpSpPr>
       <p:sp>
         <p:nvSpPr>
           <p:cNvPr id="2" name="Rectangle 1"/>
@@ -4904,6 +4962,7 @@
           <a:lstStyle/>
           <a:p>
             <a:pPr algn="ctr"/>
+            <a:endParaRPr/>
           </a:p>
         </p:txBody>
       </p:sp>
@@ -5017,6 +5076,7 @@
           <a:lstStyle/>
           <a:p>
             <a:pPr algn="ctr"/>
+            <a:endParaRPr/>
           </a:p>
         </p:txBody>
       </p:sp>
@@ -5112,7 +5172,7 @@
           </a:fontRef>
         </p:style>
         <p:txBody>
-          <a:bodyPr rtlCol="0" anchor="ctr" lIns="274320" tIns="274320"/>
+          <a:bodyPr lIns="274320" tIns="274320" rtlCol="0" anchor="ctr"/>
           <a:lstStyle/>
           <a:p>
             <a:pPr algn="ctr">
@@ -5181,7 +5241,7 @@
           </a:fontRef>
         </p:style>
         <p:txBody>
-          <a:bodyPr rtlCol="0" anchor="ctr" lIns="274320" tIns="274320"/>
+          <a:bodyPr lIns="274320" tIns="274320" rtlCol="0" anchor="ctr"/>
           <a:lstStyle/>
           <a:p>
             <a:pPr algn="ctr">
@@ -5250,7 +5310,7 @@
           </a:fontRef>
         </p:style>
         <p:txBody>
-          <a:bodyPr rtlCol="0" anchor="ctr" lIns="274320" tIns="274320"/>
+          <a:bodyPr lIns="274320" tIns="274320" rtlCol="0" anchor="ctr"/>
           <a:lstStyle/>
           <a:p>
             <a:pPr algn="ctr">
@@ -5319,7 +5379,7 @@
           </a:fontRef>
         </p:style>
         <p:txBody>
-          <a:bodyPr rtlCol="0" anchor="ctr" lIns="274320" tIns="274320"/>
+          <a:bodyPr lIns="274320" tIns="274320" rtlCol="0" anchor="ctr"/>
           <a:lstStyle/>
           <a:p>
             <a:pPr algn="ctr">
@@ -5359,7 +5419,7 @@
 </file>
 
 <file path=ppt/slides/slide14.xml><?xml version="1.0" encoding="utf-8"?>
-<p:sld xmlns:a="http://schemas.openxmlformats.org/drawingml/2006/main" xmlns:p="http://schemas.openxmlformats.org/presentationml/2006/main" xmlns:r="http://schemas.openxmlformats.org/officeDocument/2006/relationships">
+<p:sld xmlns:a="http://schemas.openxmlformats.org/drawingml/2006/main" xmlns:r="http://schemas.openxmlformats.org/officeDocument/2006/relationships" xmlns:p="http://schemas.openxmlformats.org/presentationml/2006/main">
   <p:cSld>
     <p:spTree>
       <p:nvGrpSpPr>
@@ -5367,7 +5427,14 @@
         <p:cNvGrpSpPr/>
         <p:nvPr/>
       </p:nvGrpSpPr>
-      <p:grpSpPr/>
+      <p:grpSpPr>
+        <a:xfrm>
+          <a:off x="0" y="0"/>
+          <a:ext cx="0" cy="0"/>
+          <a:chOff x="0" y="0"/>
+          <a:chExt cx="0" cy="0"/>
+        </a:xfrm>
+      </p:grpSpPr>
       <p:sp>
         <p:nvSpPr>
           <p:cNvPr id="2" name="Rectangle 1"/>
@@ -5408,6 +5475,7 @@
           <a:lstStyle/>
           <a:p>
             <a:pPr algn="ctr"/>
+            <a:endParaRPr/>
           </a:p>
         </p:txBody>
       </p:sp>
@@ -5521,6 +5589,7 @@
           <a:lstStyle/>
           <a:p>
             <a:pPr algn="ctr"/>
+            <a:endParaRPr/>
           </a:p>
         </p:txBody>
       </p:sp>
@@ -5616,7 +5685,7 @@
           </a:fontRef>
         </p:style>
         <p:txBody>
-          <a:bodyPr rtlCol="0" anchor="ctr" lIns="274320" tIns="365760"/>
+          <a:bodyPr lIns="274320" tIns="365760" rtlCol="0" anchor="ctr"/>
           <a:lstStyle/>
           <a:p>
             <a:pPr algn="ctr">
@@ -5689,7 +5758,7 @@
           </a:fontRef>
         </p:style>
         <p:txBody>
-          <a:bodyPr rtlCol="0" anchor="ctr" lIns="274320" tIns="365760"/>
+          <a:bodyPr lIns="274320" tIns="365760" rtlCol="0" anchor="ctr"/>
           <a:lstStyle/>
           <a:p>
             <a:pPr algn="ctr">
@@ -5762,7 +5831,7 @@
           </a:fontRef>
         </p:style>
         <p:txBody>
-          <a:bodyPr rtlCol="0" anchor="ctr" lIns="274320" tIns="365760"/>
+          <a:bodyPr lIns="274320" tIns="365760" rtlCol="0" anchor="ctr"/>
           <a:lstStyle/>
           <a:p>
             <a:pPr algn="ctr">
@@ -5806,7 +5875,7 @@
 </file>
 
 <file path=ppt/slides/slide15.xml><?xml version="1.0" encoding="utf-8"?>
-<p:sld xmlns:a="http://schemas.openxmlformats.org/drawingml/2006/main" xmlns:p="http://schemas.openxmlformats.org/presentationml/2006/main" xmlns:r="http://schemas.openxmlformats.org/officeDocument/2006/relationships">
+<p:sld xmlns:a="http://schemas.openxmlformats.org/drawingml/2006/main" xmlns:r="http://schemas.openxmlformats.org/officeDocument/2006/relationships" xmlns:p="http://schemas.openxmlformats.org/presentationml/2006/main">
   <p:cSld>
     <p:spTree>
       <p:nvGrpSpPr>
@@ -5814,7 +5883,14 @@
         <p:cNvGrpSpPr/>
         <p:nvPr/>
       </p:nvGrpSpPr>
-      <p:grpSpPr/>
+      <p:grpSpPr>
+        <a:xfrm>
+          <a:off x="0" y="0"/>
+          <a:ext cx="0" cy="0"/>
+          <a:chOff x="0" y="0"/>
+          <a:chExt cx="0" cy="0"/>
+        </a:xfrm>
+      </p:grpSpPr>
       <p:sp>
         <p:nvSpPr>
           <p:cNvPr id="2" name="Rectangle 1"/>
@@ -5855,6 +5931,7 @@
           <a:lstStyle/>
           <a:p>
             <a:pPr algn="ctr"/>
+            <a:endParaRPr/>
           </a:p>
         </p:txBody>
       </p:sp>
@@ -5968,6 +6045,7 @@
           <a:lstStyle/>
           <a:p>
             <a:pPr algn="ctr"/>
+            <a:endParaRPr/>
           </a:p>
         </p:txBody>
       </p:sp>
@@ -6063,7 +6141,7 @@
           </a:fontRef>
         </p:style>
         <p:txBody>
-          <a:bodyPr rtlCol="0" anchor="ctr" lIns="274320" tIns="365760"/>
+          <a:bodyPr lIns="274320" tIns="365760" rtlCol="0" anchor="ctr"/>
           <a:lstStyle/>
           <a:p>
             <a:pPr algn="ctr">
@@ -6136,7 +6214,7 @@
           </a:fontRef>
         </p:style>
         <p:txBody>
-          <a:bodyPr rtlCol="0" anchor="ctr" lIns="274320" tIns="365760"/>
+          <a:bodyPr lIns="274320" tIns="365760" rtlCol="0" anchor="ctr"/>
           <a:lstStyle/>
           <a:p>
             <a:pPr algn="ctr">
@@ -6209,7 +6287,7 @@
           </a:fontRef>
         </p:style>
         <p:txBody>
-          <a:bodyPr rtlCol="0" anchor="ctr" lIns="274320" tIns="365760"/>
+          <a:bodyPr lIns="274320" tIns="365760" rtlCol="0" anchor="ctr"/>
           <a:lstStyle/>
           <a:p>
             <a:pPr algn="ctr">
@@ -6253,7 +6331,7 @@
 </file>
 
 <file path=ppt/slides/slide16.xml><?xml version="1.0" encoding="utf-8"?>
-<p:sld xmlns:a="http://schemas.openxmlformats.org/drawingml/2006/main" xmlns:p="http://schemas.openxmlformats.org/presentationml/2006/main" xmlns:r="http://schemas.openxmlformats.org/officeDocument/2006/relationships">
+<p:sld xmlns:a="http://schemas.openxmlformats.org/drawingml/2006/main" xmlns:r="http://schemas.openxmlformats.org/officeDocument/2006/relationships" xmlns:p="http://schemas.openxmlformats.org/presentationml/2006/main">
   <p:cSld>
     <p:spTree>
       <p:nvGrpSpPr>
@@ -6261,7 +6339,14 @@
         <p:cNvGrpSpPr/>
         <p:nvPr/>
       </p:nvGrpSpPr>
-      <p:grpSpPr/>
+      <p:grpSpPr>
+        <a:xfrm>
+          <a:off x="0" y="0"/>
+          <a:ext cx="0" cy="0"/>
+          <a:chOff x="0" y="0"/>
+          <a:chExt cx="0" cy="0"/>
+        </a:xfrm>
+      </p:grpSpPr>
       <p:sp>
         <p:nvSpPr>
           <p:cNvPr id="2" name="Rectangle 1"/>
@@ -6302,6 +6387,7 @@
           <a:lstStyle/>
           <a:p>
             <a:pPr algn="ctr"/>
+            <a:endParaRPr/>
           </a:p>
         </p:txBody>
       </p:sp>
@@ -6415,6 +6501,7 @@
           <a:lstStyle/>
           <a:p>
             <a:pPr algn="ctr"/>
+            <a:endParaRPr/>
           </a:p>
         </p:txBody>
       </p:sp>
@@ -6510,7 +6597,7 @@
           </a:fontRef>
         </p:style>
         <p:txBody>
-          <a:bodyPr rtlCol="0" anchor="ctr" lIns="274320" tIns="274320"/>
+          <a:bodyPr lIns="274320" tIns="274320" rtlCol="0" anchor="ctr"/>
           <a:lstStyle/>
           <a:p>
             <a:pPr algn="ctr">
@@ -6579,7 +6666,7 @@
           </a:fontRef>
         </p:style>
         <p:txBody>
-          <a:bodyPr rtlCol="0" anchor="ctr" lIns="274320" tIns="274320"/>
+          <a:bodyPr lIns="274320" tIns="274320" rtlCol="0" anchor="ctr"/>
           <a:lstStyle/>
           <a:p>
             <a:pPr algn="ctr">
@@ -6648,7 +6735,7 @@
           </a:fontRef>
         </p:style>
         <p:txBody>
-          <a:bodyPr rtlCol="0" anchor="ctr" lIns="274320" tIns="274320"/>
+          <a:bodyPr lIns="274320" tIns="274320" rtlCol="0" anchor="ctr"/>
           <a:lstStyle/>
           <a:p>
             <a:pPr algn="ctr">
@@ -6717,7 +6804,7 @@
           </a:fontRef>
         </p:style>
         <p:txBody>
-          <a:bodyPr rtlCol="0" anchor="ctr" lIns="274320" tIns="274320"/>
+          <a:bodyPr lIns="274320" tIns="274320" rtlCol="0" anchor="ctr"/>
           <a:lstStyle/>
           <a:p>
             <a:pPr algn="ctr">
@@ -6757,7 +6844,7 @@
 </file>
 
 <file path=ppt/slides/slide17.xml><?xml version="1.0" encoding="utf-8"?>
-<p:sld xmlns:a="http://schemas.openxmlformats.org/drawingml/2006/main" xmlns:p="http://schemas.openxmlformats.org/presentationml/2006/main" xmlns:r="http://schemas.openxmlformats.org/officeDocument/2006/relationships">
+<p:sld xmlns:a="http://schemas.openxmlformats.org/drawingml/2006/main" xmlns:r="http://schemas.openxmlformats.org/officeDocument/2006/relationships" xmlns:p="http://schemas.openxmlformats.org/presentationml/2006/main">
   <p:cSld>
     <p:spTree>
       <p:nvGrpSpPr>
@@ -6765,7 +6852,14 @@
         <p:cNvGrpSpPr/>
         <p:nvPr/>
       </p:nvGrpSpPr>
-      <p:grpSpPr/>
+      <p:grpSpPr>
+        <a:xfrm>
+          <a:off x="0" y="0"/>
+          <a:ext cx="0" cy="0"/>
+          <a:chOff x="0" y="0"/>
+          <a:chExt cx="0" cy="0"/>
+        </a:xfrm>
+      </p:grpSpPr>
       <p:sp>
         <p:nvSpPr>
           <p:cNvPr id="2" name="Rectangle 1"/>
@@ -6806,6 +6900,7 @@
           <a:lstStyle/>
           <a:p>
             <a:pPr algn="ctr"/>
+            <a:endParaRPr/>
           </a:p>
         </p:txBody>
       </p:sp>
@@ -6919,6 +7014,7 @@
           <a:lstStyle/>
           <a:p>
             <a:pPr algn="ctr"/>
+            <a:endParaRPr/>
           </a:p>
         </p:txBody>
       </p:sp>
@@ -7014,7 +7110,7 @@
           </a:fontRef>
         </p:style>
         <p:txBody>
-          <a:bodyPr rtlCol="0" anchor="ctr" lIns="274320" tIns="365760"/>
+          <a:bodyPr lIns="274320" tIns="365760" rtlCol="0" anchor="ctr"/>
           <a:lstStyle/>
           <a:p>
             <a:pPr algn="ctr">
@@ -7083,7 +7179,7 @@
           </a:fontRef>
         </p:style>
         <p:txBody>
-          <a:bodyPr rtlCol="0" anchor="ctr" lIns="274320" tIns="365760"/>
+          <a:bodyPr lIns="274320" tIns="365760" rtlCol="0" anchor="ctr"/>
           <a:lstStyle/>
           <a:p>
             <a:pPr algn="ctr">
@@ -7152,7 +7248,7 @@
           </a:fontRef>
         </p:style>
         <p:txBody>
-          <a:bodyPr rtlCol="0" anchor="ctr" lIns="274320" tIns="365760"/>
+          <a:bodyPr lIns="274320" tIns="365760" rtlCol="0" anchor="ctr"/>
           <a:lstStyle/>
           <a:p>
             <a:pPr algn="ctr">
@@ -7192,7 +7288,7 @@
 </file>
 
 <file path=ppt/slides/slide18.xml><?xml version="1.0" encoding="utf-8"?>
-<p:sld xmlns:a="http://schemas.openxmlformats.org/drawingml/2006/main" xmlns:p="http://schemas.openxmlformats.org/presentationml/2006/main" xmlns:r="http://schemas.openxmlformats.org/officeDocument/2006/relationships">
+<p:sld xmlns:a="http://schemas.openxmlformats.org/drawingml/2006/main" xmlns:r="http://schemas.openxmlformats.org/officeDocument/2006/relationships" xmlns:p="http://schemas.openxmlformats.org/presentationml/2006/main">
   <p:cSld>
     <p:spTree>
       <p:nvGrpSpPr>
@@ -7200,7 +7296,14 @@
         <p:cNvGrpSpPr/>
         <p:nvPr/>
       </p:nvGrpSpPr>
-      <p:grpSpPr/>
+      <p:grpSpPr>
+        <a:xfrm>
+          <a:off x="0" y="0"/>
+          <a:ext cx="0" cy="0"/>
+          <a:chOff x="0" y="0"/>
+          <a:chExt cx="0" cy="0"/>
+        </a:xfrm>
+      </p:grpSpPr>
       <p:sp>
         <p:nvSpPr>
           <p:cNvPr id="2" name="Rectangle 1"/>
@@ -7241,6 +7344,7 @@
           <a:lstStyle/>
           <a:p>
             <a:pPr algn="ctr"/>
+            <a:endParaRPr/>
           </a:p>
         </p:txBody>
       </p:sp>
@@ -7354,6 +7458,7 @@
           <a:lstStyle/>
           <a:p>
             <a:pPr algn="ctr"/>
+            <a:endParaRPr/>
           </a:p>
         </p:txBody>
       </p:sp>
@@ -7449,7 +7554,7 @@
           </a:fontRef>
         </p:style>
         <p:txBody>
-          <a:bodyPr rtlCol="0" anchor="ctr" lIns="274320" tIns="365760"/>
+          <a:bodyPr lIns="274320" tIns="365760" rtlCol="0" anchor="ctr"/>
           <a:lstStyle/>
           <a:p>
             <a:pPr algn="ctr">
@@ -7518,7 +7623,7 @@
           </a:fontRef>
         </p:style>
         <p:txBody>
-          <a:bodyPr rtlCol="0" anchor="ctr" lIns="274320" tIns="365760"/>
+          <a:bodyPr lIns="274320" tIns="365760" rtlCol="0" anchor="ctr"/>
           <a:lstStyle/>
           <a:p>
             <a:pPr algn="ctr">
@@ -7587,7 +7692,7 @@
           </a:fontRef>
         </p:style>
         <p:txBody>
-          <a:bodyPr rtlCol="0" anchor="ctr" lIns="274320" tIns="365760"/>
+          <a:bodyPr lIns="274320" tIns="365760" rtlCol="0" anchor="ctr"/>
           <a:lstStyle/>
           <a:p>
             <a:pPr algn="ctr">
@@ -7627,7 +7732,7 @@
 </file>
 
 <file path=ppt/slides/slide19.xml><?xml version="1.0" encoding="utf-8"?>
-<p:sld xmlns:a="http://schemas.openxmlformats.org/drawingml/2006/main" xmlns:p="http://schemas.openxmlformats.org/presentationml/2006/main" xmlns:r="http://schemas.openxmlformats.org/officeDocument/2006/relationships">
+<p:sld xmlns:a="http://schemas.openxmlformats.org/drawingml/2006/main" xmlns:r="http://schemas.openxmlformats.org/officeDocument/2006/relationships" xmlns:p="http://schemas.openxmlformats.org/presentationml/2006/main">
   <p:cSld>
     <p:spTree>
       <p:nvGrpSpPr>
@@ -7635,7 +7740,14 @@
         <p:cNvGrpSpPr/>
         <p:nvPr/>
       </p:nvGrpSpPr>
-      <p:grpSpPr/>
+      <p:grpSpPr>
+        <a:xfrm>
+          <a:off x="0" y="0"/>
+          <a:ext cx="0" cy="0"/>
+          <a:chOff x="0" y="0"/>
+          <a:chExt cx="0" cy="0"/>
+        </a:xfrm>
+      </p:grpSpPr>
       <p:sp>
         <p:nvSpPr>
           <p:cNvPr id="2" name="Rectangle 1"/>
@@ -7676,6 +7788,7 @@
           <a:lstStyle/>
           <a:p>
             <a:pPr algn="ctr"/>
+            <a:endParaRPr/>
           </a:p>
         </p:txBody>
       </p:sp>
@@ -7789,6 +7902,7 @@
           <a:lstStyle/>
           <a:p>
             <a:pPr algn="ctr"/>
+            <a:endParaRPr/>
           </a:p>
         </p:txBody>
       </p:sp>
@@ -7884,7 +7998,7 @@
           </a:fontRef>
         </p:style>
         <p:txBody>
-          <a:bodyPr rtlCol="0" anchor="ctr" lIns="274320" tIns="365760"/>
+          <a:bodyPr lIns="274320" tIns="365760" rtlCol="0" anchor="ctr"/>
           <a:lstStyle/>
           <a:p>
             <a:pPr algn="ctr">
@@ -7953,7 +8067,7 @@
           </a:fontRef>
         </p:style>
         <p:txBody>
-          <a:bodyPr rtlCol="0" anchor="ctr" lIns="274320" tIns="365760"/>
+          <a:bodyPr lIns="274320" tIns="365760" rtlCol="0" anchor="ctr"/>
           <a:lstStyle/>
           <a:p>
             <a:pPr algn="ctr">
@@ -8022,7 +8136,7 @@
           </a:fontRef>
         </p:style>
         <p:txBody>
-          <a:bodyPr rtlCol="0" anchor="ctr" lIns="274320" tIns="365760"/>
+          <a:bodyPr lIns="274320" tIns="365760" rtlCol="0" anchor="ctr"/>
           <a:lstStyle/>
           <a:p>
             <a:pPr algn="ctr">
@@ -8062,7 +8176,7 @@
 </file>
 
 <file path=ppt/slides/slide2.xml><?xml version="1.0" encoding="utf-8"?>
-<p:sld xmlns:a="http://schemas.openxmlformats.org/drawingml/2006/main" xmlns:p="http://schemas.openxmlformats.org/presentationml/2006/main" xmlns:r="http://schemas.openxmlformats.org/officeDocument/2006/relationships">
+<p:sld xmlns:a="http://schemas.openxmlformats.org/drawingml/2006/main" xmlns:r="http://schemas.openxmlformats.org/officeDocument/2006/relationships" xmlns:p="http://schemas.openxmlformats.org/presentationml/2006/main">
   <p:cSld>
     <p:spTree>
       <p:nvGrpSpPr>
@@ -8070,7 +8184,14 @@
         <p:cNvGrpSpPr/>
         <p:nvPr/>
       </p:nvGrpSpPr>
-      <p:grpSpPr/>
+      <p:grpSpPr>
+        <a:xfrm>
+          <a:off x="0" y="0"/>
+          <a:ext cx="0" cy="0"/>
+          <a:chOff x="0" y="0"/>
+          <a:chExt cx="0" cy="0"/>
+        </a:xfrm>
+      </p:grpSpPr>
       <p:sp>
         <p:nvSpPr>
           <p:cNvPr id="2" name="Rectangle 1"/>
@@ -8111,6 +8232,7 @@
           <a:lstStyle/>
           <a:p>
             <a:pPr algn="ctr"/>
+            <a:endParaRPr/>
           </a:p>
         </p:txBody>
       </p:sp>
@@ -8224,6 +8346,7 @@
           <a:lstStyle/>
           <a:p>
             <a:pPr algn="ctr"/>
+            <a:endParaRPr/>
           </a:p>
         </p:txBody>
       </p:sp>
@@ -8319,7 +8442,7 @@
           </a:fontRef>
         </p:style>
         <p:txBody>
-          <a:bodyPr rtlCol="0" anchor="ctr" lIns="365760" tIns="365760"/>
+          <a:bodyPr lIns="365760" tIns="365760" rtlCol="0" anchor="ctr"/>
           <a:lstStyle/>
           <a:p>
             <a:pPr algn="ctr">
@@ -8403,7 +8526,7 @@
           </a:fontRef>
         </p:style>
         <p:txBody>
-          <a:bodyPr rtlCol="0" anchor="ctr" lIns="365760" tIns="365760"/>
+          <a:bodyPr lIns="365760" tIns="365760" rtlCol="0" anchor="ctr"/>
           <a:lstStyle/>
           <a:p>
             <a:pPr algn="ctr">
@@ -8536,7 +8659,7 @@
 </file>
 
 <file path=ppt/slides/slide20.xml><?xml version="1.0" encoding="utf-8"?>
-<p:sld xmlns:a="http://schemas.openxmlformats.org/drawingml/2006/main" xmlns:p="http://schemas.openxmlformats.org/presentationml/2006/main" xmlns:r="http://schemas.openxmlformats.org/officeDocument/2006/relationships">
+<p:sld xmlns:a="http://schemas.openxmlformats.org/drawingml/2006/main" xmlns:r="http://schemas.openxmlformats.org/officeDocument/2006/relationships" xmlns:p="http://schemas.openxmlformats.org/presentationml/2006/main">
   <p:cSld>
     <p:spTree>
       <p:nvGrpSpPr>
@@ -8544,7 +8667,14 @@
         <p:cNvGrpSpPr/>
         <p:nvPr/>
       </p:nvGrpSpPr>
-      <p:grpSpPr/>
+      <p:grpSpPr>
+        <a:xfrm>
+          <a:off x="0" y="0"/>
+          <a:ext cx="0" cy="0"/>
+          <a:chOff x="0" y="0"/>
+          <a:chExt cx="0" cy="0"/>
+        </a:xfrm>
+      </p:grpSpPr>
       <p:sp>
         <p:nvSpPr>
           <p:cNvPr id="2" name="Rectangle 1"/>
@@ -8585,6 +8715,7 @@
           <a:lstStyle/>
           <a:p>
             <a:pPr algn="ctr"/>
+            <a:endParaRPr/>
           </a:p>
         </p:txBody>
       </p:sp>
@@ -8698,6 +8829,7 @@
           <a:lstStyle/>
           <a:p>
             <a:pPr algn="ctr"/>
+            <a:endParaRPr/>
           </a:p>
         </p:txBody>
       </p:sp>
@@ -8793,7 +8925,7 @@
           </a:fontRef>
         </p:style>
         <p:txBody>
-          <a:bodyPr rtlCol="0" anchor="ctr" lIns="274320" tIns="274320"/>
+          <a:bodyPr lIns="274320" tIns="274320" rtlCol="0" anchor="ctr"/>
           <a:lstStyle/>
           <a:p>
             <a:pPr algn="ctr">
@@ -8862,7 +8994,7 @@
           </a:fontRef>
         </p:style>
         <p:txBody>
-          <a:bodyPr rtlCol="0" anchor="ctr" lIns="274320" tIns="274320"/>
+          <a:bodyPr lIns="274320" tIns="274320" rtlCol="0" anchor="ctr"/>
           <a:lstStyle/>
           <a:p>
             <a:pPr algn="ctr">
@@ -8931,7 +9063,7 @@
           </a:fontRef>
         </p:style>
         <p:txBody>
-          <a:bodyPr rtlCol="0" anchor="ctr" lIns="274320" tIns="274320"/>
+          <a:bodyPr lIns="274320" tIns="274320" rtlCol="0" anchor="ctr"/>
           <a:lstStyle/>
           <a:p>
             <a:pPr algn="ctr">
@@ -9000,7 +9132,7 @@
           </a:fontRef>
         </p:style>
         <p:txBody>
-          <a:bodyPr rtlCol="0" anchor="ctr" lIns="274320" tIns="274320"/>
+          <a:bodyPr lIns="274320" tIns="274320" rtlCol="0" anchor="ctr"/>
           <a:lstStyle/>
           <a:p>
             <a:pPr algn="ctr">
@@ -9040,7 +9172,7 @@
 </file>
 
 <file path=ppt/slides/slide21.xml><?xml version="1.0" encoding="utf-8"?>
-<p:sld xmlns:a="http://schemas.openxmlformats.org/drawingml/2006/main" xmlns:p="http://schemas.openxmlformats.org/presentationml/2006/main" xmlns:r="http://schemas.openxmlformats.org/officeDocument/2006/relationships">
+<p:sld xmlns:a="http://schemas.openxmlformats.org/drawingml/2006/main" xmlns:r="http://schemas.openxmlformats.org/officeDocument/2006/relationships" xmlns:p="http://schemas.openxmlformats.org/presentationml/2006/main">
   <p:cSld>
     <p:spTree>
       <p:nvGrpSpPr>
@@ -9048,7 +9180,14 @@
         <p:cNvGrpSpPr/>
         <p:nvPr/>
       </p:nvGrpSpPr>
-      <p:grpSpPr/>
+      <p:grpSpPr>
+        <a:xfrm>
+          <a:off x="0" y="0"/>
+          <a:ext cx="0" cy="0"/>
+          <a:chOff x="0" y="0"/>
+          <a:chExt cx="0" cy="0"/>
+        </a:xfrm>
+      </p:grpSpPr>
       <p:sp>
         <p:nvSpPr>
           <p:cNvPr id="2" name="Rectangle 1"/>
@@ -9089,6 +9228,7 @@
           <a:lstStyle/>
           <a:p>
             <a:pPr algn="ctr"/>
+            <a:endParaRPr/>
           </a:p>
         </p:txBody>
       </p:sp>
@@ -9202,6 +9342,7 @@
           <a:lstStyle/>
           <a:p>
             <a:pPr algn="ctr"/>
+            <a:endParaRPr/>
           </a:p>
         </p:txBody>
       </p:sp>
@@ -9297,7 +9438,7 @@
           </a:fontRef>
         </p:style>
         <p:txBody>
-          <a:bodyPr rtlCol="0" anchor="ctr" lIns="365760" tIns="365760"/>
+          <a:bodyPr lIns="365760" tIns="365760" rtlCol="0" anchor="ctr"/>
           <a:lstStyle/>
           <a:p>
             <a:pPr algn="ctr">
@@ -9459,7 +9600,7 @@
           </a:fontRef>
         </p:style>
         <p:txBody>
-          <a:bodyPr rtlCol="0" anchor="ctr" lIns="274320" tIns="274320"/>
+          <a:bodyPr lIns="274320" tIns="274320" rtlCol="0" anchor="ctr"/>
           <a:lstStyle/>
           <a:p>
             <a:pPr algn="ctr">
@@ -9549,7 +9690,7 @@
 </file>
 
 <file path=ppt/slides/slide22.xml><?xml version="1.0" encoding="utf-8"?>
-<p:sld xmlns:a="http://schemas.openxmlformats.org/drawingml/2006/main" xmlns:p="http://schemas.openxmlformats.org/presentationml/2006/main" xmlns:r="http://schemas.openxmlformats.org/officeDocument/2006/relationships">
+<p:sld xmlns:a="http://schemas.openxmlformats.org/drawingml/2006/main" xmlns:r="http://schemas.openxmlformats.org/officeDocument/2006/relationships" xmlns:p="http://schemas.openxmlformats.org/presentationml/2006/main">
   <p:cSld>
     <p:spTree>
       <p:nvGrpSpPr>
@@ -9557,7 +9698,14 @@
         <p:cNvGrpSpPr/>
         <p:nvPr/>
       </p:nvGrpSpPr>
-      <p:grpSpPr/>
+      <p:grpSpPr>
+        <a:xfrm>
+          <a:off x="0" y="0"/>
+          <a:ext cx="0" cy="0"/>
+          <a:chOff x="0" y="0"/>
+          <a:chExt cx="0" cy="0"/>
+        </a:xfrm>
+      </p:grpSpPr>
       <p:sp>
         <p:nvSpPr>
           <p:cNvPr id="2" name="Rectangle 1"/>
@@ -9598,6 +9746,7 @@
           <a:lstStyle/>
           <a:p>
             <a:pPr algn="ctr"/>
+            <a:endParaRPr/>
           </a:p>
         </p:txBody>
       </p:sp>
@@ -9711,6 +9860,7 @@
           <a:lstStyle/>
           <a:p>
             <a:pPr algn="ctr"/>
+            <a:endParaRPr/>
           </a:p>
         </p:txBody>
       </p:sp>
@@ -9806,7 +9956,7 @@
           </a:fontRef>
         </p:style>
         <p:txBody>
-          <a:bodyPr rtlCol="0" anchor="ctr" lIns="274320" tIns="365760"/>
+          <a:bodyPr lIns="274320" tIns="365760" rtlCol="0" anchor="ctr"/>
           <a:lstStyle/>
           <a:p>
             <a:pPr algn="ctr">
@@ -9879,7 +10029,7 @@
           </a:fontRef>
         </p:style>
         <p:txBody>
-          <a:bodyPr rtlCol="0" anchor="ctr" lIns="274320" tIns="365760"/>
+          <a:bodyPr lIns="274320" tIns="365760" rtlCol="0" anchor="ctr"/>
           <a:lstStyle/>
           <a:p>
             <a:pPr algn="ctr">
@@ -9952,7 +10102,7 @@
           </a:fontRef>
         </p:style>
         <p:txBody>
-          <a:bodyPr rtlCol="0" anchor="ctr" lIns="274320" tIns="365760"/>
+          <a:bodyPr lIns="274320" tIns="365760" rtlCol="0" anchor="ctr"/>
           <a:lstStyle/>
           <a:p>
             <a:pPr algn="ctr">
@@ -9996,7 +10146,7 @@
 </file>
 
 <file path=ppt/slides/slide23.xml><?xml version="1.0" encoding="utf-8"?>
-<p:sld xmlns:a="http://schemas.openxmlformats.org/drawingml/2006/main" xmlns:p="http://schemas.openxmlformats.org/presentationml/2006/main" xmlns:r="http://schemas.openxmlformats.org/officeDocument/2006/relationships">
+<p:sld xmlns:a="http://schemas.openxmlformats.org/drawingml/2006/main" xmlns:r="http://schemas.openxmlformats.org/officeDocument/2006/relationships" xmlns:p="http://schemas.openxmlformats.org/presentationml/2006/main">
   <p:cSld>
     <p:spTree>
       <p:nvGrpSpPr>
@@ -10004,7 +10154,14 @@
         <p:cNvGrpSpPr/>
         <p:nvPr/>
       </p:nvGrpSpPr>
-      <p:grpSpPr/>
+      <p:grpSpPr>
+        <a:xfrm>
+          <a:off x="0" y="0"/>
+          <a:ext cx="0" cy="0"/>
+          <a:chOff x="0" y="0"/>
+          <a:chExt cx="0" cy="0"/>
+        </a:xfrm>
+      </p:grpSpPr>
       <p:sp>
         <p:nvSpPr>
           <p:cNvPr id="2" name="Rectangle 1"/>
@@ -10045,6 +10202,7 @@
           <a:lstStyle/>
           <a:p>
             <a:pPr algn="ctr"/>
+            <a:endParaRPr/>
           </a:p>
         </p:txBody>
       </p:sp>
@@ -10158,6 +10316,7 @@
           <a:lstStyle/>
           <a:p>
             <a:pPr algn="ctr"/>
+            <a:endParaRPr/>
           </a:p>
         </p:txBody>
       </p:sp>
@@ -10253,7 +10412,7 @@
           </a:fontRef>
         </p:style>
         <p:txBody>
-          <a:bodyPr rtlCol="0" anchor="ctr" lIns="365760" tIns="365760"/>
+          <a:bodyPr lIns="365760" tIns="365760" rtlCol="0" anchor="ctr"/>
           <a:lstStyle/>
           <a:p>
             <a:pPr algn="ctr">
@@ -10369,7 +10528,7 @@
 </file>
 
 <file path=ppt/slides/slide24.xml><?xml version="1.0" encoding="utf-8"?>
-<p:sld xmlns:a="http://schemas.openxmlformats.org/drawingml/2006/main" xmlns:p="http://schemas.openxmlformats.org/presentationml/2006/main" xmlns:r="http://schemas.openxmlformats.org/officeDocument/2006/relationships">
+<p:sld xmlns:a="http://schemas.openxmlformats.org/drawingml/2006/main" xmlns:r="http://schemas.openxmlformats.org/officeDocument/2006/relationships" xmlns:p="http://schemas.openxmlformats.org/presentationml/2006/main">
   <p:cSld>
     <p:spTree>
       <p:nvGrpSpPr>
@@ -10377,7 +10536,14 @@
         <p:cNvGrpSpPr/>
         <p:nvPr/>
       </p:nvGrpSpPr>
-      <p:grpSpPr/>
+      <p:grpSpPr>
+        <a:xfrm>
+          <a:off x="0" y="0"/>
+          <a:ext cx="0" cy="0"/>
+          <a:chOff x="0" y="0"/>
+          <a:chExt cx="0" cy="0"/>
+        </a:xfrm>
+      </p:grpSpPr>
       <p:sp>
         <p:nvSpPr>
           <p:cNvPr id="2" name="Rectangle 1"/>
@@ -10418,6 +10584,7 @@
           <a:lstStyle/>
           <a:p>
             <a:pPr algn="ctr"/>
+            <a:endParaRPr/>
           </a:p>
         </p:txBody>
       </p:sp>
@@ -10429,7 +10596,7 @@
         </p:nvSpPr>
         <p:spPr>
           <a:xfrm>
-            <a:off x="1371600" y="914400"/>
+            <a:off x="841248" y="1088136"/>
             <a:ext cx="9448495" cy="5029200"/>
           </a:xfrm>
           <a:prstGeom prst="roundRect">
@@ -10459,7 +10626,7 @@
           </a:fontRef>
         </p:style>
         <p:txBody>
-          <a:bodyPr rtlCol="0" anchor="ctr" lIns="548640" rIns="548640" tIns="548640"/>
+          <a:bodyPr lIns="548640" tIns="548640" rIns="548640" rtlCol="0" anchor="ctr"/>
           <a:lstStyle/>
           <a:p>
             <a:pPr algn="ctr">
@@ -10548,7 +10715,7 @@
 </file>
 
 <file path=ppt/slides/slide3.xml><?xml version="1.0" encoding="utf-8"?>
-<p:sld xmlns:a="http://schemas.openxmlformats.org/drawingml/2006/main" xmlns:p="http://schemas.openxmlformats.org/presentationml/2006/main" xmlns:r="http://schemas.openxmlformats.org/officeDocument/2006/relationships">
+<p:sld xmlns:a="http://schemas.openxmlformats.org/drawingml/2006/main" xmlns:r="http://schemas.openxmlformats.org/officeDocument/2006/relationships" xmlns:p="http://schemas.openxmlformats.org/presentationml/2006/main">
   <p:cSld>
     <p:spTree>
       <p:nvGrpSpPr>
@@ -10556,7 +10723,14 @@
         <p:cNvGrpSpPr/>
         <p:nvPr/>
       </p:nvGrpSpPr>
-      <p:grpSpPr/>
+      <p:grpSpPr>
+        <a:xfrm>
+          <a:off x="0" y="0"/>
+          <a:ext cx="0" cy="0"/>
+          <a:chOff x="0" y="0"/>
+          <a:chExt cx="0" cy="0"/>
+        </a:xfrm>
+      </p:grpSpPr>
       <p:sp>
         <p:nvSpPr>
           <p:cNvPr id="2" name="Rectangle 1"/>
@@ -10597,6 +10771,7 @@
           <a:lstStyle/>
           <a:p>
             <a:pPr algn="ctr"/>
+            <a:endParaRPr/>
           </a:p>
         </p:txBody>
       </p:sp>
@@ -10710,6 +10885,7 @@
           <a:lstStyle/>
           <a:p>
             <a:pPr algn="ctr"/>
+            <a:endParaRPr/>
           </a:p>
         </p:txBody>
       </p:sp>
@@ -10805,7 +10981,7 @@
           </a:fontRef>
         </p:style>
         <p:txBody>
-          <a:bodyPr rtlCol="0" anchor="ctr" lIns="365760" tIns="365760"/>
+          <a:bodyPr lIns="365760" tIns="365760" rtlCol="0" anchor="ctr"/>
           <a:lstStyle/>
           <a:p>
             <a:pPr algn="ctr">
@@ -10913,7 +11089,7 @@
           </a:fontRef>
         </p:style>
         <p:txBody>
-          <a:bodyPr rtlCol="0" anchor="ctr" lIns="365760" tIns="365760"/>
+          <a:bodyPr lIns="365760" tIns="365760" rtlCol="0" anchor="ctr"/>
           <a:lstStyle/>
           <a:p>
             <a:pPr algn="ctr">
@@ -10992,7 +11168,7 @@
 </file>
 
 <file path=ppt/slides/slide4.xml><?xml version="1.0" encoding="utf-8"?>
-<p:sld xmlns:a="http://schemas.openxmlformats.org/drawingml/2006/main" xmlns:p="http://schemas.openxmlformats.org/presentationml/2006/main" xmlns:r="http://schemas.openxmlformats.org/officeDocument/2006/relationships">
+<p:sld xmlns:a="http://schemas.openxmlformats.org/drawingml/2006/main" xmlns:r="http://schemas.openxmlformats.org/officeDocument/2006/relationships" xmlns:p="http://schemas.openxmlformats.org/presentationml/2006/main">
   <p:cSld>
     <p:spTree>
       <p:nvGrpSpPr>
@@ -11000,7 +11176,14 @@
         <p:cNvGrpSpPr/>
         <p:nvPr/>
       </p:nvGrpSpPr>
-      <p:grpSpPr/>
+      <p:grpSpPr>
+        <a:xfrm>
+          <a:off x="0" y="0"/>
+          <a:ext cx="0" cy="0"/>
+          <a:chOff x="0" y="0"/>
+          <a:chExt cx="0" cy="0"/>
+        </a:xfrm>
+      </p:grpSpPr>
       <p:sp>
         <p:nvSpPr>
           <p:cNvPr id="2" name="Rectangle 1"/>
@@ -11041,6 +11224,7 @@
           <a:lstStyle/>
           <a:p>
             <a:pPr algn="ctr"/>
+            <a:endParaRPr/>
           </a:p>
         </p:txBody>
       </p:sp>
@@ -11154,6 +11338,7 @@
           <a:lstStyle/>
           <a:p>
             <a:pPr algn="ctr"/>
+            <a:endParaRPr/>
           </a:p>
         </p:txBody>
       </p:sp>
@@ -11249,7 +11434,7 @@
           </a:fontRef>
         </p:style>
         <p:txBody>
-          <a:bodyPr rtlCol="0" anchor="ctr" lIns="365760" tIns="365760"/>
+          <a:bodyPr lIns="365760" tIns="365760" rtlCol="0" anchor="ctr"/>
           <a:lstStyle/>
           <a:p>
             <a:pPr algn="ctr">
@@ -11357,7 +11542,7 @@
           </a:fontRef>
         </p:style>
         <p:txBody>
-          <a:bodyPr rtlCol="0" anchor="ctr" lIns="365760" tIns="365760"/>
+          <a:bodyPr lIns="365760" tIns="365760" rtlCol="0" anchor="ctr"/>
           <a:lstStyle/>
           <a:p>
             <a:pPr algn="ctr">
@@ -11436,7 +11621,7 @@
 </file>
 
 <file path=ppt/slides/slide5.xml><?xml version="1.0" encoding="utf-8"?>
-<p:sld xmlns:a="http://schemas.openxmlformats.org/drawingml/2006/main" xmlns:p="http://schemas.openxmlformats.org/presentationml/2006/main" xmlns:r="http://schemas.openxmlformats.org/officeDocument/2006/relationships">
+<p:sld xmlns:a="http://schemas.openxmlformats.org/drawingml/2006/main" xmlns:r="http://schemas.openxmlformats.org/officeDocument/2006/relationships" xmlns:p="http://schemas.openxmlformats.org/presentationml/2006/main">
   <p:cSld>
     <p:spTree>
       <p:nvGrpSpPr>
@@ -11444,7 +11629,14 @@
         <p:cNvGrpSpPr/>
         <p:nvPr/>
       </p:nvGrpSpPr>
-      <p:grpSpPr/>
+      <p:grpSpPr>
+        <a:xfrm>
+          <a:off x="0" y="0"/>
+          <a:ext cx="0" cy="0"/>
+          <a:chOff x="0" y="0"/>
+          <a:chExt cx="0" cy="0"/>
+        </a:xfrm>
+      </p:grpSpPr>
       <p:sp>
         <p:nvSpPr>
           <p:cNvPr id="2" name="Rectangle 1"/>
@@ -11485,6 +11677,7 @@
           <a:lstStyle/>
           <a:p>
             <a:pPr algn="ctr"/>
+            <a:endParaRPr/>
           </a:p>
         </p:txBody>
       </p:sp>
@@ -11598,6 +11791,7 @@
           <a:lstStyle/>
           <a:p>
             <a:pPr algn="ctr"/>
+            <a:endParaRPr/>
           </a:p>
         </p:txBody>
       </p:sp>
@@ -11693,7 +11887,7 @@
           </a:fontRef>
         </p:style>
         <p:txBody>
-          <a:bodyPr rtlCol="0" anchor="ctr" lIns="365760" tIns="365760"/>
+          <a:bodyPr lIns="365760" tIns="365760" rtlCol="0" anchor="ctr"/>
           <a:lstStyle/>
           <a:p>
             <a:pPr algn="ctr">
@@ -11801,7 +11995,7 @@
           </a:fontRef>
         </p:style>
         <p:txBody>
-          <a:bodyPr rtlCol="0" anchor="ctr" lIns="365760" tIns="365760"/>
+          <a:bodyPr lIns="365760" tIns="365760" rtlCol="0" anchor="ctr"/>
           <a:lstStyle/>
           <a:p>
             <a:pPr algn="ctr">
@@ -11880,7 +12074,7 @@
 </file>
 
 <file path=ppt/slides/slide6.xml><?xml version="1.0" encoding="utf-8"?>
-<p:sld xmlns:a="http://schemas.openxmlformats.org/drawingml/2006/main" xmlns:p="http://schemas.openxmlformats.org/presentationml/2006/main" xmlns:r="http://schemas.openxmlformats.org/officeDocument/2006/relationships">
+<p:sld xmlns:a="http://schemas.openxmlformats.org/drawingml/2006/main" xmlns:r="http://schemas.openxmlformats.org/officeDocument/2006/relationships" xmlns:p="http://schemas.openxmlformats.org/presentationml/2006/main">
   <p:cSld>
     <p:spTree>
       <p:nvGrpSpPr>
@@ -11888,7 +12082,14 @@
         <p:cNvGrpSpPr/>
         <p:nvPr/>
       </p:nvGrpSpPr>
-      <p:grpSpPr/>
+      <p:grpSpPr>
+        <a:xfrm>
+          <a:off x="0" y="0"/>
+          <a:ext cx="0" cy="0"/>
+          <a:chOff x="0" y="0"/>
+          <a:chExt cx="0" cy="0"/>
+        </a:xfrm>
+      </p:grpSpPr>
       <p:sp>
         <p:nvSpPr>
           <p:cNvPr id="2" name="Rectangle 1"/>
@@ -11929,6 +12130,7 @@
           <a:lstStyle/>
           <a:p>
             <a:pPr algn="ctr"/>
+            <a:endParaRPr/>
           </a:p>
         </p:txBody>
       </p:sp>
@@ -12042,6 +12244,7 @@
           <a:lstStyle/>
           <a:p>
             <a:pPr algn="ctr"/>
+            <a:endParaRPr/>
           </a:p>
         </p:txBody>
       </p:sp>
@@ -12137,7 +12340,7 @@
           </a:fontRef>
         </p:style>
         <p:txBody>
-          <a:bodyPr rtlCol="0" anchor="ctr" lIns="274320" tIns="274320"/>
+          <a:bodyPr lIns="274320" tIns="274320" rtlCol="0" anchor="ctr"/>
           <a:lstStyle/>
           <a:p>
             <a:pPr algn="ctr">
@@ -12206,7 +12409,7 @@
           </a:fontRef>
         </p:style>
         <p:txBody>
-          <a:bodyPr rtlCol="0" anchor="ctr" lIns="274320" tIns="274320"/>
+          <a:bodyPr lIns="274320" tIns="274320" rtlCol="0" anchor="ctr"/>
           <a:lstStyle/>
           <a:p>
             <a:pPr algn="ctr">
@@ -12275,7 +12478,7 @@
           </a:fontRef>
         </p:style>
         <p:txBody>
-          <a:bodyPr rtlCol="0" anchor="ctr" lIns="274320" tIns="274320"/>
+          <a:bodyPr lIns="274320" tIns="274320" rtlCol="0" anchor="ctr"/>
           <a:lstStyle/>
           <a:p>
             <a:pPr algn="ctr">
@@ -12344,7 +12547,7 @@
           </a:fontRef>
         </p:style>
         <p:txBody>
-          <a:bodyPr rtlCol="0" anchor="ctr" lIns="274320" tIns="274320"/>
+          <a:bodyPr lIns="274320" tIns="274320" rtlCol="0" anchor="ctr"/>
           <a:lstStyle/>
           <a:p>
             <a:pPr algn="ctr">
@@ -12384,7 +12587,7 @@
 </file>
 
 <file path=ppt/slides/slide7.xml><?xml version="1.0" encoding="utf-8"?>
-<p:sld xmlns:a="http://schemas.openxmlformats.org/drawingml/2006/main" xmlns:p="http://schemas.openxmlformats.org/presentationml/2006/main" xmlns:r="http://schemas.openxmlformats.org/officeDocument/2006/relationships">
+<p:sld xmlns:a="http://schemas.openxmlformats.org/drawingml/2006/main" xmlns:r="http://schemas.openxmlformats.org/officeDocument/2006/relationships" xmlns:p="http://schemas.openxmlformats.org/presentationml/2006/main">
   <p:cSld>
     <p:spTree>
       <p:nvGrpSpPr>
@@ -12392,7 +12595,14 @@
         <p:cNvGrpSpPr/>
         <p:nvPr/>
       </p:nvGrpSpPr>
-      <p:grpSpPr/>
+      <p:grpSpPr>
+        <a:xfrm>
+          <a:off x="0" y="0"/>
+          <a:ext cx="0" cy="0"/>
+          <a:chOff x="0" y="0"/>
+          <a:chExt cx="0" cy="0"/>
+        </a:xfrm>
+      </p:grpSpPr>
       <p:sp>
         <p:nvSpPr>
           <p:cNvPr id="2" name="Rectangle 1"/>
@@ -12433,6 +12643,7 @@
           <a:lstStyle/>
           <a:p>
             <a:pPr algn="ctr"/>
+            <a:endParaRPr/>
           </a:p>
         </p:txBody>
       </p:sp>
@@ -12546,6 +12757,7 @@
           <a:lstStyle/>
           <a:p>
             <a:pPr algn="ctr"/>
+            <a:endParaRPr/>
           </a:p>
         </p:txBody>
       </p:sp>
@@ -12641,7 +12853,7 @@
           </a:fontRef>
         </p:style>
         <p:txBody>
-          <a:bodyPr rtlCol="0" anchor="ctr" lIns="274320" tIns="274320"/>
+          <a:bodyPr lIns="274320" tIns="274320" rtlCol="0" anchor="ctr"/>
           <a:lstStyle/>
           <a:p>
             <a:pPr algn="ctr">
@@ -12710,7 +12922,7 @@
           </a:fontRef>
         </p:style>
         <p:txBody>
-          <a:bodyPr rtlCol="0" anchor="ctr" lIns="274320" tIns="274320"/>
+          <a:bodyPr lIns="274320" tIns="274320" rtlCol="0" anchor="ctr"/>
           <a:lstStyle/>
           <a:p>
             <a:pPr algn="ctr">
@@ -12779,7 +12991,7 @@
           </a:fontRef>
         </p:style>
         <p:txBody>
-          <a:bodyPr rtlCol="0" anchor="ctr" lIns="274320" tIns="274320"/>
+          <a:bodyPr lIns="274320" tIns="274320" rtlCol="0" anchor="ctr"/>
           <a:lstStyle/>
           <a:p>
             <a:pPr algn="ctr">
@@ -12848,7 +13060,7 @@
           </a:fontRef>
         </p:style>
         <p:txBody>
-          <a:bodyPr rtlCol="0" anchor="ctr" lIns="274320" tIns="274320"/>
+          <a:bodyPr lIns="274320" tIns="274320" rtlCol="0" anchor="ctr"/>
           <a:lstStyle/>
           <a:p>
             <a:pPr algn="ctr">
@@ -12888,7 +13100,7 @@
 </file>
 
 <file path=ppt/slides/slide8.xml><?xml version="1.0" encoding="utf-8"?>
-<p:sld xmlns:a="http://schemas.openxmlformats.org/drawingml/2006/main" xmlns:p="http://schemas.openxmlformats.org/presentationml/2006/main" xmlns:r="http://schemas.openxmlformats.org/officeDocument/2006/relationships">
+<p:sld xmlns:a="http://schemas.openxmlformats.org/drawingml/2006/main" xmlns:r="http://schemas.openxmlformats.org/officeDocument/2006/relationships" xmlns:p="http://schemas.openxmlformats.org/presentationml/2006/main">
   <p:cSld>
     <p:spTree>
       <p:nvGrpSpPr>
@@ -12896,7 +13108,14 @@
         <p:cNvGrpSpPr/>
         <p:nvPr/>
       </p:nvGrpSpPr>
-      <p:grpSpPr/>
+      <p:grpSpPr>
+        <a:xfrm>
+          <a:off x="0" y="0"/>
+          <a:ext cx="0" cy="0"/>
+          <a:chOff x="0" y="0"/>
+          <a:chExt cx="0" cy="0"/>
+        </a:xfrm>
+      </p:grpSpPr>
       <p:sp>
         <p:nvSpPr>
           <p:cNvPr id="2" name="Rectangle 1"/>
@@ -12937,6 +13156,7 @@
           <a:lstStyle/>
           <a:p>
             <a:pPr algn="ctr"/>
+            <a:endParaRPr/>
           </a:p>
         </p:txBody>
       </p:sp>
@@ -13050,6 +13270,7 @@
           <a:lstStyle/>
           <a:p>
             <a:pPr algn="ctr"/>
+            <a:endParaRPr/>
           </a:p>
         </p:txBody>
       </p:sp>
@@ -13145,7 +13366,7 @@
           </a:fontRef>
         </p:style>
         <p:txBody>
-          <a:bodyPr rtlCol="0" anchor="ctr" lIns="274320" tIns="365760"/>
+          <a:bodyPr lIns="274320" tIns="365760" rtlCol="0" anchor="ctr"/>
           <a:lstStyle/>
           <a:p>
             <a:pPr algn="ctr">
@@ -13234,7 +13455,7 @@
           </a:fontRef>
         </p:style>
         <p:txBody>
-          <a:bodyPr rtlCol="0" anchor="ctr" lIns="274320" tIns="365760"/>
+          <a:bodyPr lIns="274320" tIns="365760" rtlCol="0" anchor="ctr"/>
           <a:lstStyle/>
           <a:p>
             <a:pPr algn="ctr">
@@ -13323,7 +13544,7 @@
           </a:fontRef>
         </p:style>
         <p:txBody>
-          <a:bodyPr rtlCol="0" anchor="ctr" lIns="274320" tIns="365760"/>
+          <a:bodyPr lIns="274320" tIns="365760" rtlCol="0" anchor="ctr"/>
           <a:lstStyle/>
           <a:p>
             <a:pPr algn="ctr">
@@ -13383,7 +13604,7 @@
 </file>
 
 <file path=ppt/slides/slide9.xml><?xml version="1.0" encoding="utf-8"?>
-<p:sld xmlns:a="http://schemas.openxmlformats.org/drawingml/2006/main" xmlns:p="http://schemas.openxmlformats.org/presentationml/2006/main" xmlns:r="http://schemas.openxmlformats.org/officeDocument/2006/relationships">
+<p:sld xmlns:a="http://schemas.openxmlformats.org/drawingml/2006/main" xmlns:r="http://schemas.openxmlformats.org/officeDocument/2006/relationships" xmlns:p="http://schemas.openxmlformats.org/presentationml/2006/main">
   <p:cSld>
     <p:spTree>
       <p:nvGrpSpPr>
@@ -13391,7 +13612,14 @@
         <p:cNvGrpSpPr/>
         <p:nvPr/>
       </p:nvGrpSpPr>
-      <p:grpSpPr/>
+      <p:grpSpPr>
+        <a:xfrm>
+          <a:off x="0" y="0"/>
+          <a:ext cx="0" cy="0"/>
+          <a:chOff x="0" y="0"/>
+          <a:chExt cx="0" cy="0"/>
+        </a:xfrm>
+      </p:grpSpPr>
       <p:sp>
         <p:nvSpPr>
           <p:cNvPr id="2" name="Rectangle 1"/>
@@ -13432,6 +13660,7 @@
           <a:lstStyle/>
           <a:p>
             <a:pPr algn="ctr"/>
+            <a:endParaRPr/>
           </a:p>
         </p:txBody>
       </p:sp>
@@ -13545,6 +13774,7 @@
           <a:lstStyle/>
           <a:p>
             <a:pPr algn="ctr"/>
+            <a:endParaRPr/>
           </a:p>
         </p:txBody>
       </p:sp>
@@ -13640,7 +13870,7 @@
           </a:fontRef>
         </p:style>
         <p:txBody>
-          <a:bodyPr rtlCol="0" anchor="ctr" lIns="365760" tIns="365760"/>
+          <a:bodyPr lIns="365760" tIns="365760" rtlCol="0" anchor="ctr"/>
           <a:lstStyle/>
           <a:p>
             <a:pPr algn="ctr">
@@ -13748,7 +13978,7 @@
           </a:fontRef>
         </p:style>
         <p:txBody>
-          <a:bodyPr rtlCol="0" anchor="ctr" lIns="365760" tIns="365760"/>
+          <a:bodyPr lIns="365760" tIns="365760" rtlCol="0" anchor="ctr"/>
           <a:lstStyle/>
           <a:p>
             <a:pPr algn="ctr">

</xml_diff>